<commit_message>
in class edit l6
</commit_message>
<xml_diff>
--- a/pptx/Lecture6.pptx
+++ b/pptx/Lecture6.pptx
@@ -485,7 +485,7 @@
           <a:p>
             <a:fld id="{4995A223-E7C9-A243-9A70-FE01E1A1DD65}" type="datetimeFigureOut">
               <a:rPr lang="en-US" smtClean="0"/>
-              <a:t>9/17/2026</a:t>
+              <a:t>9/17/26</a:t>
             </a:fld>
             <a:endParaRPr lang="en-US"/>
           </a:p>
@@ -1460,7 +1460,7 @@
           <a:p>
             <a:fld id="{1BF61C71-767E-B84C-BFB3-7B18856D27F4}" type="datetimeFigureOut">
               <a:rPr lang="en-US" smtClean="0"/>
-              <a:t>9/17/2026</a:t>
+              <a:t>9/17/26</a:t>
             </a:fld>
             <a:endParaRPr lang="en-US"/>
           </a:p>
@@ -1668,7 +1668,7 @@
           <a:p>
             <a:fld id="{1BF61C71-767E-B84C-BFB3-7B18856D27F4}" type="datetimeFigureOut">
               <a:rPr lang="en-US" smtClean="0"/>
-              <a:t>9/17/2026</a:t>
+              <a:t>9/17/26</a:t>
             </a:fld>
             <a:endParaRPr lang="en-US"/>
           </a:p>
@@ -1886,7 +1886,7 @@
           <a:p>
             <a:fld id="{1BF61C71-767E-B84C-BFB3-7B18856D27F4}" type="datetimeFigureOut">
               <a:rPr lang="en-US" smtClean="0"/>
-              <a:t>9/17/2026</a:t>
+              <a:t>9/17/26</a:t>
             </a:fld>
             <a:endParaRPr lang="en-US"/>
           </a:p>
@@ -2094,7 +2094,7 @@
           <a:p>
             <a:fld id="{1BF61C71-767E-B84C-BFB3-7B18856D27F4}" type="datetimeFigureOut">
               <a:rPr lang="en-US" smtClean="0"/>
-              <a:t>9/17/2026</a:t>
+              <a:t>9/17/26</a:t>
             </a:fld>
             <a:endParaRPr lang="en-US"/>
           </a:p>
@@ -2378,7 +2378,7 @@
           <a:p>
             <a:fld id="{1BF61C71-767E-B84C-BFB3-7B18856D27F4}" type="datetimeFigureOut">
               <a:rPr lang="en-US" smtClean="0"/>
-              <a:t>9/17/2026</a:t>
+              <a:t>9/17/26</a:t>
             </a:fld>
             <a:endParaRPr lang="en-US"/>
           </a:p>
@@ -2654,7 +2654,7 @@
           <a:p>
             <a:fld id="{1BF61C71-767E-B84C-BFB3-7B18856D27F4}" type="datetimeFigureOut">
               <a:rPr lang="en-US" smtClean="0"/>
-              <a:t>9/17/2026</a:t>
+              <a:t>9/17/26</a:t>
             </a:fld>
             <a:endParaRPr lang="en-US"/>
           </a:p>
@@ -3077,7 +3077,7 @@
           <a:p>
             <a:fld id="{1BF61C71-767E-B84C-BFB3-7B18856D27F4}" type="datetimeFigureOut">
               <a:rPr lang="en-US" smtClean="0"/>
-              <a:t>9/17/2026</a:t>
+              <a:t>9/17/26</a:t>
             </a:fld>
             <a:endParaRPr lang="en-US"/>
           </a:p>
@@ -3227,7 +3227,7 @@
           <a:p>
             <a:fld id="{1BF61C71-767E-B84C-BFB3-7B18856D27F4}" type="datetimeFigureOut">
               <a:rPr lang="en-US" smtClean="0"/>
-              <a:t>9/17/2026</a:t>
+              <a:t>9/17/26</a:t>
             </a:fld>
             <a:endParaRPr lang="en-US"/>
           </a:p>
@@ -3348,7 +3348,7 @@
           <a:p>
             <a:fld id="{1BF61C71-767E-B84C-BFB3-7B18856D27F4}" type="datetimeFigureOut">
               <a:rPr lang="en-US" smtClean="0"/>
-              <a:t>9/17/2026</a:t>
+              <a:t>9/17/26</a:t>
             </a:fld>
             <a:endParaRPr lang="en-US"/>
           </a:p>
@@ -3669,7 +3669,7 @@
           <a:p>
             <a:fld id="{1BF61C71-767E-B84C-BFB3-7B18856D27F4}" type="datetimeFigureOut">
               <a:rPr lang="en-US" smtClean="0"/>
-              <a:t>9/17/2026</a:t>
+              <a:t>9/17/26</a:t>
             </a:fld>
             <a:endParaRPr lang="en-US"/>
           </a:p>
@@ -3966,7 +3966,7 @@
           <a:p>
             <a:fld id="{1BF61C71-767E-B84C-BFB3-7B18856D27F4}" type="datetimeFigureOut">
               <a:rPr lang="en-US" smtClean="0"/>
-              <a:t>9/17/2026</a:t>
+              <a:t>9/17/26</a:t>
             </a:fld>
             <a:endParaRPr lang="en-US"/>
           </a:p>
@@ -4220,7 +4220,7 @@
           <a:p>
             <a:fld id="{1BF61C71-767E-B84C-BFB3-7B18856D27F4}" type="datetimeFigureOut">
               <a:rPr lang="en-US" smtClean="0"/>
-              <a:t>9/17/2026</a:t>
+              <a:t>9/17/26</a:t>
             </a:fld>
             <a:endParaRPr lang="en-US"/>
           </a:p>
@@ -10022,7 +10022,7 @@
 </file>
 
 <file path=ppt/slides/slide19.xml><?xml version="1.0" encoding="utf-8"?>
-<p:sld xmlns:a="http://schemas.openxmlformats.org/drawingml/2006/main" xmlns:r="http://schemas.openxmlformats.org/officeDocument/2006/relationships" xmlns:p="http://schemas.openxmlformats.org/presentationml/2006/main">
+<p:sld xmlns:a="http://schemas.openxmlformats.org/drawingml/2006/main" xmlns:r="http://schemas.openxmlformats.org/officeDocument/2006/relationships" xmlns:p="http://schemas.openxmlformats.org/presentationml/2006/main" show="0">
   <p:cSld>
     <p:spTree>
       <p:nvGrpSpPr>

</xml_diff>